<commit_message>
Lessons: Hudi as a table layer and QUIC per-stream behaviour in sd-02-027
Co-Authored-By: Claude Opus 5.5 <noreply@anthropic.com>
Claude-Session: https://claude.ai/code/session_01McBLtMnJbTnB94NeVs8a2V
</commit_message>
<xml_diff>
--- a/system-design-101/vi/lessons/sd-02-027/slides/sd-02-027.pptx
+++ b/system-design-101/vi/lessons/sd-02-027/slides/sd-02-027.pptx
@@ -3911,7 +3911,7 @@
                         <a:buNone/>
                       </a:pPr>
                       <a:r>
-                        <a:rPr lang="en-US" sz="2100" dirty="0" spc="0" kern="0">
+                        <a:rPr lang="en-US" sz="2100" dirty="0" spc="-20" kern="0">
                           <a:solidFill>
                             <a:srgbClr val="E4E1D8"/>
                           </a:solidFill>
@@ -3919,18 +3919,7 @@
                           <a:ea typeface="Be Vietnam Pro" pitchFamily="34" charset="-122"/>
                           <a:cs typeface="Be Vietnam Pro" pitchFamily="34" charset="-120"/>
                         </a:rPr>
-                        <a:t>giao</a:t>
-                      </a:r>
-                      <a:r>
-                        <a:rPr lang="en-US" sz="2100" dirty="0" spc="6" kern="0">
-                          <a:solidFill>
-                            <a:srgbClr val="E4E1D8"/>
-                          </a:solidFill>
-                          <a:latin typeface="Be Vietnam Pro" pitchFamily="34" charset="0"/>
-                          <a:ea typeface="Be Vietnam Pro" pitchFamily="34" charset="-122"/>
-                          <a:cs typeface="Be Vietnam Pro" pitchFamily="34" charset="-120"/>
-                        </a:rPr>
-                        <a:t> thức</a:t>
+                        <a:t>trên</a:t>
                       </a:r>
                       <a:r>
                         <a:rPr lang="en-US" sz="2100" dirty="0" spc="0" kern="0">
@@ -3941,10 +3930,10 @@
                           <a:ea typeface="Be Vietnam Pro" pitchFamily="34" charset="-122"/>
                           <a:cs typeface="Be Vietnam Pro" pitchFamily="34" charset="-120"/>
                         </a:rPr>
-                        <a:t> nhanh,</a:t>
+                        <a:t> UDP,</a:t>
                       </a:r>
                       <a:r>
-                        <a:rPr lang="en-US" sz="2100" dirty="0" spc="-9" kern="0">
+                        <a:rPr lang="en-US" sz="2100" dirty="0" spc="1" kern="0">
                           <a:solidFill>
                             <a:srgbClr val="E4E1D8"/>
                           </a:solidFill>
@@ -3952,10 +3941,10 @@
                           <a:ea typeface="Be Vietnam Pro" pitchFamily="34" charset="-122"/>
                           <a:cs typeface="Be Vietnam Pro" pitchFamily="34" charset="-120"/>
                         </a:rPr>
-                        <a:t> chạy</a:t>
+                        <a:t> nhiều</a:t>
                       </a:r>
                       <a:r>
-                        <a:rPr lang="en-US" sz="2100" dirty="0" spc="-17" kern="0">
+                        <a:rPr lang="en-US" sz="2100" dirty="0" spc="-1" kern="0">
                           <a:solidFill>
                             <a:srgbClr val="E4E1D8"/>
                           </a:solidFill>
@@ -3963,10 +3952,10 @@
                           <a:ea typeface="Be Vietnam Pro" pitchFamily="34" charset="-122"/>
                           <a:cs typeface="Be Vietnam Pro" pitchFamily="34" charset="-120"/>
                         </a:rPr>
-                        <a:t> trên</a:t>
+                        <a:t> luồng</a:t>
                       </a:r>
                       <a:r>
-                        <a:rPr lang="en-US" sz="2100" dirty="0" spc="0" kern="0">
+                        <a:rPr lang="en-US" sz="2100" dirty="0" spc="5" kern="0">
                           <a:solidFill>
                             <a:srgbClr val="E4E1D8"/>
                           </a:solidFill>
@@ -3974,7 +3963,18 @@
                           <a:ea typeface="Be Vietnam Pro" pitchFamily="34" charset="-122"/>
                           <a:cs typeface="Be Vietnam Pro" pitchFamily="34" charset="-120"/>
                         </a:rPr>
-                        <a:t> UDP</a:t>
+                        <a:t> độc</a:t>
+                      </a:r>
+                      <a:r>
+                        <a:rPr lang="en-US" sz="2100" dirty="0" spc="-4" kern="0">
+                          <a:solidFill>
+                            <a:srgbClr val="E4E1D8"/>
+                          </a:solidFill>
+                          <a:latin typeface="Be Vietnam Pro" pitchFamily="34" charset="0"/>
+                          <a:ea typeface="Be Vietnam Pro" pitchFamily="34" charset="-122"/>
+                          <a:cs typeface="Be Vietnam Pro" pitchFamily="34" charset="-120"/>
+                        </a:rPr>
+                        <a:t> lập</a:t>
                       </a:r>
                       <a:endParaRPr lang="en-US" sz="1200" dirty="0"/>
                     </a:p>

</xml_diff>

<commit_message>
sd-02-027: glossary entry for the DB in AresDB and RocksDB
Co-Authored-By: Claude Opus 5.5 <noreply@anthropic.com>
Claude-Session: https://claude.ai/code/session_01McBLtMnJbTnB94NeVs8a2V
</commit_message>
<xml_diff>
--- a/system-design-101/vi/lessons/sd-02-027/slides/sd-02-027.pptx
+++ b/system-design-101/vi/lessons/sd-02-027/slides/sd-02-027.pptx
@@ -3034,7 +3034,7 @@
                 <a:gridCol w="1905000"/>
                 <a:gridCol w="6096000"/>
               </a:tblGrid>
-              <a:tr h="742950">
+              <a:tr h="685800">
                 <a:tc>
                   <a:txBody>
                     <a:bodyPr/>
@@ -3162,7 +3162,7 @@
                   </a:tcPr>
                 </a:tc>
               </a:tr>
-              <a:tr h="742950">
+              <a:tr h="685800">
                 <a:tc>
                   <a:txBody>
                     <a:bodyPr/>
@@ -3335,7 +3335,7 @@
                   </a:tcPr>
                 </a:tc>
               </a:tr>
-              <a:tr h="742950">
+              <a:tr h="685800">
                 <a:tc>
                   <a:txBody>
                     <a:bodyPr/>
@@ -3519,7 +3519,7 @@
                   </a:tcPr>
                 </a:tc>
               </a:tr>
-              <a:tr h="742950">
+              <a:tr h="685800">
                 <a:tc>
                   <a:txBody>
                     <a:bodyPr/>
@@ -3670,7 +3670,7 @@
                   </a:tcPr>
                 </a:tc>
               </a:tr>
-              <a:tr h="742950">
+              <a:tr h="685800">
                 <a:tc>
                   <a:txBody>
                     <a:bodyPr/>
@@ -3843,7 +3843,7 @@
                   </a:tcPr>
                 </a:tc>
               </a:tr>
-              <a:tr h="742950">
+              <a:tr h="685800">
                 <a:tc>
                   <a:txBody>
                     <a:bodyPr/>
@@ -4016,6 +4016,179 @@
                   </a:tcPr>
                 </a:tc>
               </a:tr>
+              <a:tr h="685800">
+                <a:tc>
+                  <a:txBody>
+                    <a:bodyPr/>
+                    <a:lstStyle/>
+                    <a:p>
+                      <a:pPr algn="l" indent="0" marL="0">
+                        <a:lnSpc>
+                          <a:spcPts val="2520"/>
+                        </a:lnSpc>
+                        <a:buNone/>
+                      </a:pPr>
+                      <a:r>
+                        <a:rPr lang="en-US" sz="2100" b="1" dirty="0" spc="4" kern="0">
+                          <a:solidFill>
+                            <a:srgbClr val="7C93FF"/>
+                          </a:solidFill>
+                          <a:latin typeface="Be Vietnam Pro" pitchFamily="34" charset="0"/>
+                          <a:ea typeface="Be Vietnam Pro" pitchFamily="34" charset="-122"/>
+                          <a:cs typeface="Be Vietnam Pro" pitchFamily="34" charset="-120"/>
+                        </a:rPr>
+                        <a:t>UDP</a:t>
+                      </a:r>
+                      <a:endParaRPr lang="en-US" sz="1200" dirty="0"/>
+                    </a:p>
+                  </a:txBody>
+                  <a:tcPr marL="76200" marR="76200" marT="76200" marB="76200">
+                    <a:lnL w="9525" cap="flat" cmpd="sng" algn="ctr">
+                      <a:solidFill>
+                        <a:srgbClr val="2D3140"/>
+                      </a:solidFill>
+                      <a:prstDash val="solid"/>
+                      <a:round/>
+                      <a:headEnd type="none" w="med" len="med"/>
+                      <a:tailEnd type="none" w="med" len="med"/>
+                    </a:lnL>
+                    <a:lnR w="0" cap="flat" cmpd="sng" algn="ctr">
+                      <a:noFill/>
+                    </a:lnR>
+                    <a:lnT w="9525" cap="flat" cmpd="sng" algn="ctr">
+                      <a:solidFill>
+                        <a:srgbClr val="2D3140"/>
+                      </a:solidFill>
+                      <a:prstDash val="solid"/>
+                      <a:round/>
+                      <a:headEnd type="none" w="med" len="med"/>
+                      <a:tailEnd type="none" w="med" len="med"/>
+                    </a:lnT>
+                    <a:lnB w="0" cap="flat" cmpd="sng" algn="ctr">
+                      <a:noFill/>
+                    </a:lnB>
+                    <a:solidFill>
+                      <a:srgbClr val="14161C"/>
+                    </a:solidFill>
+                  </a:tcPr>
+                </a:tc>
+                <a:tc>
+                  <a:txBody>
+                    <a:bodyPr/>
+                    <a:lstStyle/>
+                    <a:p>
+                      <a:pPr algn="l" indent="0" marL="0">
+                        <a:lnSpc>
+                          <a:spcPts val="2520"/>
+                        </a:lnSpc>
+                        <a:buNone/>
+                      </a:pPr>
+                      <a:r>
+                        <a:rPr lang="en-US" sz="2100" dirty="0" spc="48" kern="0">
+                          <a:solidFill>
+                            <a:srgbClr val="E4E1D8"/>
+                          </a:solidFill>
+                          <a:latin typeface="Be Vietnam Pro" pitchFamily="34" charset="0"/>
+                          <a:ea typeface="Be Vietnam Pro" pitchFamily="34" charset="-122"/>
+                          <a:cs typeface="Be Vietnam Pro" pitchFamily="34" charset="-120"/>
+                        </a:rPr>
+                        <a:t>gửi</a:t>
+                      </a:r>
+                      <a:r>
+                        <a:rPr lang="en-US" sz="2100" dirty="0" spc="-12" kern="0">
+                          <a:solidFill>
+                            <a:srgbClr val="E4E1D8"/>
+                          </a:solidFill>
+                          <a:latin typeface="Be Vietnam Pro" pitchFamily="34" charset="0"/>
+                          <a:ea typeface="Be Vietnam Pro" pitchFamily="34" charset="-122"/>
+                          <a:cs typeface="Be Vietnam Pro" pitchFamily="34" charset="-120"/>
+                        </a:rPr>
+                        <a:t> gói</a:t>
+                      </a:r>
+                      <a:r>
+                        <a:rPr lang="en-US" sz="2100" dirty="0" spc="1" kern="0">
+                          <a:solidFill>
+                            <a:srgbClr val="E4E1D8"/>
+                          </a:solidFill>
+                          <a:latin typeface="Be Vietnam Pro" pitchFamily="34" charset="0"/>
+                          <a:ea typeface="Be Vietnam Pro" pitchFamily="34" charset="-122"/>
+                          <a:cs typeface="Be Vietnam Pro" pitchFamily="34" charset="-120"/>
+                        </a:rPr>
+                        <a:t> tin</a:t>
+                      </a:r>
+                      <a:r>
+                        <a:rPr lang="en-US" sz="2100" dirty="0" spc="-1" kern="0">
+                          <a:solidFill>
+                            <a:srgbClr val="E4E1D8"/>
+                          </a:solidFill>
+                          <a:latin typeface="Be Vietnam Pro" pitchFamily="34" charset="0"/>
+                          <a:ea typeface="Be Vietnam Pro" pitchFamily="34" charset="-122"/>
+                          <a:cs typeface="Be Vietnam Pro" pitchFamily="34" charset="-120"/>
+                        </a:rPr>
+                        <a:t> không cần</a:t>
+                      </a:r>
+                      <a:r>
+                        <a:rPr lang="en-US" sz="2100" dirty="0" spc="-17" kern="0">
+                          <a:solidFill>
+                            <a:srgbClr val="E4E1D8"/>
+                          </a:solidFill>
+                          <a:latin typeface="Be Vietnam Pro" pitchFamily="34" charset="0"/>
+                          <a:ea typeface="Be Vietnam Pro" pitchFamily="34" charset="-122"/>
+                          <a:cs typeface="Be Vietnam Pro" pitchFamily="34" charset="-120"/>
+                        </a:rPr>
+                        <a:t> bắt</a:t>
+                      </a:r>
+                      <a:r>
+                        <a:rPr lang="en-US" sz="2100" dirty="0" spc="-20" kern="0">
+                          <a:solidFill>
+                            <a:srgbClr val="E4E1D8"/>
+                          </a:solidFill>
+                          <a:latin typeface="Be Vietnam Pro" pitchFamily="34" charset="0"/>
+                          <a:ea typeface="Be Vietnam Pro" pitchFamily="34" charset="-122"/>
+                          <a:cs typeface="Be Vietnam Pro" pitchFamily="34" charset="-120"/>
+                        </a:rPr>
+                        <a:t> tay</a:t>
+                      </a:r>
+                      <a:endParaRPr lang="en-US" sz="1200" dirty="0"/>
+                    </a:p>
+                  </a:txBody>
+                  <a:tcPr marL="76200" marR="76200" marT="76200" marB="76200">
+                    <a:lnL w="9525" cap="flat" cmpd="sng" algn="ctr">
+                      <a:solidFill>
+                        <a:srgbClr val="2D3140"/>
+                      </a:solidFill>
+                      <a:prstDash val="solid"/>
+                      <a:round/>
+                      <a:headEnd type="none" w="med" len="med"/>
+                      <a:tailEnd type="none" w="med" len="med"/>
+                    </a:lnL>
+                    <a:lnR w="9525" cap="flat" cmpd="sng" algn="ctr">
+                      <a:solidFill>
+                        <a:srgbClr val="2D3140"/>
+                      </a:solidFill>
+                      <a:prstDash val="solid"/>
+                      <a:round/>
+                      <a:headEnd type="none" w="med" len="med"/>
+                      <a:tailEnd type="none" w="med" len="med"/>
+                    </a:lnR>
+                    <a:lnT w="9525" cap="flat" cmpd="sng" algn="ctr">
+                      <a:solidFill>
+                        <a:srgbClr val="2D3140"/>
+                      </a:solidFill>
+                      <a:prstDash val="solid"/>
+                      <a:round/>
+                      <a:headEnd type="none" w="med" len="med"/>
+                      <a:tailEnd type="none" w="med" len="med"/>
+                    </a:lnT>
+                    <a:lnB w="0" cap="flat" cmpd="sng" algn="ctr">
+                      <a:noFill/>
+                    </a:lnB>
+                    <a:solidFill>
+                      <a:srgbClr val="14161C"/>
+                    </a:solidFill>
+                  </a:tcPr>
+                </a:tc>
+              </a:tr>
             </a:tbl>
           </a:graphicData>
         </a:graphic>
@@ -4046,7 +4219,7 @@
                 <a:gridCol w="1905000"/>
                 <a:gridCol w="6096000"/>
               </a:tblGrid>
-              <a:tr h="742950">
+              <a:tr h="685800">
                 <a:tc>
                   <a:txBody>
                     <a:bodyPr/>
@@ -4174,180 +4347,7 @@
                   </a:tcPr>
                 </a:tc>
               </a:tr>
-              <a:tr h="742950">
-                <a:tc>
-                  <a:txBody>
-                    <a:bodyPr/>
-                    <a:lstStyle/>
-                    <a:p>
-                      <a:pPr algn="l" indent="0" marL="0">
-                        <a:lnSpc>
-                          <a:spcPts val="2520"/>
-                        </a:lnSpc>
-                        <a:buNone/>
-                      </a:pPr>
-                      <a:r>
-                        <a:rPr lang="en-US" sz="2100" b="1" dirty="0" spc="4" kern="0">
-                          <a:solidFill>
-                            <a:srgbClr val="7C93FF"/>
-                          </a:solidFill>
-                          <a:latin typeface="Be Vietnam Pro" pitchFamily="34" charset="0"/>
-                          <a:ea typeface="Be Vietnam Pro" pitchFamily="34" charset="-122"/>
-                          <a:cs typeface="Be Vietnam Pro" pitchFamily="34" charset="-120"/>
-                        </a:rPr>
-                        <a:t>UDP</a:t>
-                      </a:r>
-                      <a:endParaRPr lang="en-US" sz="1200" dirty="0"/>
-                    </a:p>
-                  </a:txBody>
-                  <a:tcPr marL="76200" marR="76200" marT="76200" marB="76200">
-                    <a:lnL w="9525" cap="flat" cmpd="sng" algn="ctr">
-                      <a:solidFill>
-                        <a:srgbClr val="2D3140"/>
-                      </a:solidFill>
-                      <a:prstDash val="solid"/>
-                      <a:round/>
-                      <a:headEnd type="none" w="med" len="med"/>
-                      <a:tailEnd type="none" w="med" len="med"/>
-                    </a:lnL>
-                    <a:lnR w="0" cap="flat" cmpd="sng" algn="ctr">
-                      <a:noFill/>
-                    </a:lnR>
-                    <a:lnT w="9525" cap="flat" cmpd="sng" algn="ctr">
-                      <a:solidFill>
-                        <a:srgbClr val="2D3140"/>
-                      </a:solidFill>
-                      <a:prstDash val="solid"/>
-                      <a:round/>
-                      <a:headEnd type="none" w="med" len="med"/>
-                      <a:tailEnd type="none" w="med" len="med"/>
-                    </a:lnT>
-                    <a:lnB w="0" cap="flat" cmpd="sng" algn="ctr">
-                      <a:noFill/>
-                    </a:lnB>
-                    <a:solidFill>
-                      <a:srgbClr val="1A1D25"/>
-                    </a:solidFill>
-                  </a:tcPr>
-                </a:tc>
-                <a:tc>
-                  <a:txBody>
-                    <a:bodyPr/>
-                    <a:lstStyle/>
-                    <a:p>
-                      <a:pPr algn="l" indent="0" marL="0">
-                        <a:lnSpc>
-                          <a:spcPts val="2520"/>
-                        </a:lnSpc>
-                        <a:buNone/>
-                      </a:pPr>
-                      <a:r>
-                        <a:rPr lang="en-US" sz="2100" dirty="0" spc="48" kern="0">
-                          <a:solidFill>
-                            <a:srgbClr val="E4E1D8"/>
-                          </a:solidFill>
-                          <a:latin typeface="Be Vietnam Pro" pitchFamily="34" charset="0"/>
-                          <a:ea typeface="Be Vietnam Pro" pitchFamily="34" charset="-122"/>
-                          <a:cs typeface="Be Vietnam Pro" pitchFamily="34" charset="-120"/>
-                        </a:rPr>
-                        <a:t>gửi</a:t>
-                      </a:r>
-                      <a:r>
-                        <a:rPr lang="en-US" sz="2100" dirty="0" spc="-12" kern="0">
-                          <a:solidFill>
-                            <a:srgbClr val="E4E1D8"/>
-                          </a:solidFill>
-                          <a:latin typeface="Be Vietnam Pro" pitchFamily="34" charset="0"/>
-                          <a:ea typeface="Be Vietnam Pro" pitchFamily="34" charset="-122"/>
-                          <a:cs typeface="Be Vietnam Pro" pitchFamily="34" charset="-120"/>
-                        </a:rPr>
-                        <a:t> gói</a:t>
-                      </a:r>
-                      <a:r>
-                        <a:rPr lang="en-US" sz="2100" dirty="0" spc="1" kern="0">
-                          <a:solidFill>
-                            <a:srgbClr val="E4E1D8"/>
-                          </a:solidFill>
-                          <a:latin typeface="Be Vietnam Pro" pitchFamily="34" charset="0"/>
-                          <a:ea typeface="Be Vietnam Pro" pitchFamily="34" charset="-122"/>
-                          <a:cs typeface="Be Vietnam Pro" pitchFamily="34" charset="-120"/>
-                        </a:rPr>
-                        <a:t> tin</a:t>
-                      </a:r>
-                      <a:r>
-                        <a:rPr lang="en-US" sz="2100" dirty="0" spc="-1" kern="0">
-                          <a:solidFill>
-                            <a:srgbClr val="E4E1D8"/>
-                          </a:solidFill>
-                          <a:latin typeface="Be Vietnam Pro" pitchFamily="34" charset="0"/>
-                          <a:ea typeface="Be Vietnam Pro" pitchFamily="34" charset="-122"/>
-                          <a:cs typeface="Be Vietnam Pro" pitchFamily="34" charset="-120"/>
-                        </a:rPr>
-                        <a:t> không cần</a:t>
-                      </a:r>
-                      <a:r>
-                        <a:rPr lang="en-US" sz="2100" dirty="0" spc="-17" kern="0">
-                          <a:solidFill>
-                            <a:srgbClr val="E4E1D8"/>
-                          </a:solidFill>
-                          <a:latin typeface="Be Vietnam Pro" pitchFamily="34" charset="0"/>
-                          <a:ea typeface="Be Vietnam Pro" pitchFamily="34" charset="-122"/>
-                          <a:cs typeface="Be Vietnam Pro" pitchFamily="34" charset="-120"/>
-                        </a:rPr>
-                        <a:t> bắt</a:t>
-                      </a:r>
-                      <a:r>
-                        <a:rPr lang="en-US" sz="2100" dirty="0" spc="-20" kern="0">
-                          <a:solidFill>
-                            <a:srgbClr val="E4E1D8"/>
-                          </a:solidFill>
-                          <a:latin typeface="Be Vietnam Pro" pitchFamily="34" charset="0"/>
-                          <a:ea typeface="Be Vietnam Pro" pitchFamily="34" charset="-122"/>
-                          <a:cs typeface="Be Vietnam Pro" pitchFamily="34" charset="-120"/>
-                        </a:rPr>
-                        <a:t> tay</a:t>
-                      </a:r>
-                      <a:endParaRPr lang="en-US" sz="1200" dirty="0"/>
-                    </a:p>
-                  </a:txBody>
-                  <a:tcPr marL="76200" marR="76200" marT="76200" marB="76200">
-                    <a:lnL w="9525" cap="flat" cmpd="sng" algn="ctr">
-                      <a:solidFill>
-                        <a:srgbClr val="2D3140"/>
-                      </a:solidFill>
-                      <a:prstDash val="solid"/>
-                      <a:round/>
-                      <a:headEnd type="none" w="med" len="med"/>
-                      <a:tailEnd type="none" w="med" len="med"/>
-                    </a:lnL>
-                    <a:lnR w="9525" cap="flat" cmpd="sng" algn="ctr">
-                      <a:solidFill>
-                        <a:srgbClr val="2D3140"/>
-                      </a:solidFill>
-                      <a:prstDash val="solid"/>
-                      <a:round/>
-                      <a:headEnd type="none" w="med" len="med"/>
-                      <a:tailEnd type="none" w="med" len="med"/>
-                    </a:lnR>
-                    <a:lnT w="9525" cap="flat" cmpd="sng" algn="ctr">
-                      <a:solidFill>
-                        <a:srgbClr val="2D3140"/>
-                      </a:solidFill>
-                      <a:prstDash val="solid"/>
-                      <a:round/>
-                      <a:headEnd type="none" w="med" len="med"/>
-                      <a:tailEnd type="none" w="med" len="med"/>
-                    </a:lnT>
-                    <a:lnB w="0" cap="flat" cmpd="sng" algn="ctr">
-                      <a:noFill/>
-                    </a:lnB>
-                    <a:solidFill>
-                      <a:srgbClr val="1A1D25"/>
-                    </a:solidFill>
-                  </a:tcPr>
-                </a:tc>
-              </a:tr>
-              <a:tr h="742950">
+              <a:tr h="685800">
                 <a:tc>
                   <a:txBody>
                     <a:bodyPr/>
@@ -4399,7 +4399,7 @@
                       <a:noFill/>
                     </a:lnB>
                     <a:solidFill>
-                      <a:srgbClr val="14161C"/>
+                      <a:srgbClr val="1A1D25"/>
                     </a:solidFill>
                   </a:tcPr>
                 </a:tc>
@@ -4504,12 +4504,12 @@
                       <a:noFill/>
                     </a:lnB>
                     <a:solidFill>
-                      <a:srgbClr val="14161C"/>
+                      <a:srgbClr val="1A1D25"/>
                     </a:solidFill>
                   </a:tcPr>
                 </a:tc>
               </a:tr>
-              <a:tr h="742950">
+              <a:tr h="685800">
                 <a:tc>
                   <a:txBody>
                     <a:bodyPr/>
@@ -4561,7 +4561,7 @@
                       <a:noFill/>
                     </a:lnB>
                     <a:solidFill>
-                      <a:srgbClr val="1A1D25"/>
+                      <a:srgbClr val="14161C"/>
                     </a:solidFill>
                   </a:tcPr>
                 </a:tc>
@@ -4688,12 +4688,196 @@
                       <a:noFill/>
                     </a:lnB>
                     <a:solidFill>
+                      <a:srgbClr val="14161C"/>
+                    </a:solidFill>
+                  </a:tcPr>
+                </a:tc>
+              </a:tr>
+              <a:tr h="685800">
+                <a:tc>
+                  <a:txBody>
+                    <a:bodyPr/>
+                    <a:lstStyle/>
+                    <a:p>
+                      <a:pPr algn="l" indent="0" marL="0">
+                        <a:lnSpc>
+                          <a:spcPts val="2520"/>
+                        </a:lnSpc>
+                        <a:buNone/>
+                      </a:pPr>
+                      <a:r>
+                        <a:rPr lang="en-US" sz="2100" b="1" dirty="0" spc="2" kern="0">
+                          <a:solidFill>
+                            <a:srgbClr val="FFB454"/>
+                          </a:solidFill>
+                          <a:latin typeface="Be Vietnam Pro" pitchFamily="34" charset="0"/>
+                          <a:ea typeface="Be Vietnam Pro" pitchFamily="34" charset="-122"/>
+                          <a:cs typeface="Be Vietnam Pro" pitchFamily="34" charset="-120"/>
+                        </a:rPr>
+                        <a:t>DB</a:t>
+                      </a:r>
+                      <a:endParaRPr lang="en-US" sz="1200" dirty="0"/>
+                    </a:p>
+                  </a:txBody>
+                  <a:tcPr marL="76200" marR="76200" marT="76200" marB="76200">
+                    <a:lnL w="9525" cap="flat" cmpd="sng" algn="ctr">
+                      <a:solidFill>
+                        <a:srgbClr val="2D3140"/>
+                      </a:solidFill>
+                      <a:prstDash val="solid"/>
+                      <a:round/>
+                      <a:headEnd type="none" w="med" len="med"/>
+                      <a:tailEnd type="none" w="med" len="med"/>
+                    </a:lnL>
+                    <a:lnR w="0" cap="flat" cmpd="sng" algn="ctr">
+                      <a:noFill/>
+                    </a:lnR>
+                    <a:lnT w="9525" cap="flat" cmpd="sng" algn="ctr">
+                      <a:solidFill>
+                        <a:srgbClr val="2D3140"/>
+                      </a:solidFill>
+                      <a:prstDash val="solid"/>
+                      <a:round/>
+                      <a:headEnd type="none" w="med" len="med"/>
+                      <a:tailEnd type="none" w="med" len="med"/>
+                    </a:lnT>
+                    <a:lnB w="0" cap="flat" cmpd="sng" algn="ctr">
+                      <a:noFill/>
+                    </a:lnB>
+                    <a:solidFill>
+                      <a:srgbClr val="1A1D25"/>
+                    </a:solidFill>
+                  </a:tcPr>
+                </a:tc>
+                <a:tc>
+                  <a:txBody>
+                    <a:bodyPr/>
+                    <a:lstStyle/>
+                    <a:p>
+                      <a:pPr algn="l" indent="0" marL="0">
+                        <a:lnSpc>
+                          <a:spcPts val="2520"/>
+                        </a:lnSpc>
+                        <a:buNone/>
+                      </a:pPr>
+                      <a:r>
+                        <a:rPr lang="en-US" sz="2100" dirty="0" spc="-1" kern="0">
+                          <a:solidFill>
+                            <a:srgbClr val="E4E1D8"/>
+                          </a:solidFill>
+                          <a:latin typeface="Be Vietnam Pro" pitchFamily="34" charset="0"/>
+                          <a:ea typeface="Be Vietnam Pro" pitchFamily="34" charset="-122"/>
+                          <a:cs typeface="Be Vietnam Pro" pitchFamily="34" charset="-120"/>
+                        </a:rPr>
+                        <a:t>cơ</a:t>
+                      </a:r>
+                      <a:r>
+                        <a:rPr lang="en-US" sz="2100" dirty="0" spc="-9" kern="0">
+                          <a:solidFill>
+                            <a:srgbClr val="E4E1D8"/>
+                          </a:solidFill>
+                          <a:latin typeface="Be Vietnam Pro" pitchFamily="34" charset="0"/>
+                          <a:ea typeface="Be Vietnam Pro" pitchFamily="34" charset="-122"/>
+                          <a:cs typeface="Be Vietnam Pro" pitchFamily="34" charset="-120"/>
+                        </a:rPr>
+                        <a:t> sở</a:t>
+                      </a:r>
+                      <a:r>
+                        <a:rPr lang="en-US" sz="2100" dirty="0" spc="-2" kern="0">
+                          <a:solidFill>
+                            <a:srgbClr val="E4E1D8"/>
+                          </a:solidFill>
+                          <a:latin typeface="Be Vietnam Pro" pitchFamily="34" charset="0"/>
+                          <a:ea typeface="Be Vietnam Pro" pitchFamily="34" charset="-122"/>
+                          <a:cs typeface="Be Vietnam Pro" pitchFamily="34" charset="-120"/>
+                        </a:rPr>
+                        <a:t> dữ</a:t>
+                      </a:r>
+                      <a:r>
+                        <a:rPr lang="en-US" sz="2100" dirty="0" spc="0" kern="0">
+                          <a:solidFill>
+                            <a:srgbClr val="E4E1D8"/>
+                          </a:solidFill>
+                          <a:latin typeface="Be Vietnam Pro" pitchFamily="34" charset="0"/>
+                          <a:ea typeface="Be Vietnam Pro" pitchFamily="34" charset="-122"/>
+                          <a:cs typeface="Be Vietnam Pro" pitchFamily="34" charset="-120"/>
+                        </a:rPr>
+                        <a:t> liệu,</a:t>
+                      </a:r>
+                      <a:r>
+                        <a:rPr lang="en-US" sz="2100" dirty="0" spc="-15" kern="0">
+                          <a:solidFill>
+                            <a:srgbClr val="E4E1D8"/>
+                          </a:solidFill>
+                          <a:latin typeface="Be Vietnam Pro" pitchFamily="34" charset="0"/>
+                          <a:ea typeface="Be Vietnam Pro" pitchFamily="34" charset="-122"/>
+                          <a:cs typeface="Be Vietnam Pro" pitchFamily="34" charset="-120"/>
+                        </a:rPr>
+                        <a:t> trong</a:t>
+                      </a:r>
+                      <a:r>
+                        <a:rPr lang="en-US" sz="2100" dirty="0" spc="-11" kern="0">
+                          <a:solidFill>
+                            <a:srgbClr val="E4E1D8"/>
+                          </a:solidFill>
+                          <a:latin typeface="Be Vietnam Pro" pitchFamily="34" charset="0"/>
+                          <a:ea typeface="Be Vietnam Pro" pitchFamily="34" charset="-122"/>
+                          <a:cs typeface="Be Vietnam Pro" pitchFamily="34" charset="-120"/>
+                        </a:rPr>
+                        <a:t> AresDB,</a:t>
+                      </a:r>
+                      <a:r>
+                        <a:rPr lang="en-US" sz="2100" dirty="0" spc="-18" kern="0">
+                          <a:solidFill>
+                            <a:srgbClr val="E4E1D8"/>
+                          </a:solidFill>
+                          <a:latin typeface="Be Vietnam Pro" pitchFamily="34" charset="0"/>
+                          <a:ea typeface="Be Vietnam Pro" pitchFamily="34" charset="-122"/>
+                          <a:cs typeface="Be Vietnam Pro" pitchFamily="34" charset="-120"/>
+                        </a:rPr>
+                        <a:t> RocksDB</a:t>
+                      </a:r>
+                      <a:endParaRPr lang="en-US" sz="1200" dirty="0"/>
+                    </a:p>
+                  </a:txBody>
+                  <a:tcPr marL="76200" marR="76200" marT="76200" marB="76200">
+                    <a:lnL w="9525" cap="flat" cmpd="sng" algn="ctr">
+                      <a:solidFill>
+                        <a:srgbClr val="2D3140"/>
+                      </a:solidFill>
+                      <a:prstDash val="solid"/>
+                      <a:round/>
+                      <a:headEnd type="none" w="med" len="med"/>
+                      <a:tailEnd type="none" w="med" len="med"/>
+                    </a:lnL>
+                    <a:lnR w="9525" cap="flat" cmpd="sng" algn="ctr">
+                      <a:solidFill>
+                        <a:srgbClr val="2D3140"/>
+                      </a:solidFill>
+                      <a:prstDash val="solid"/>
+                      <a:round/>
+                      <a:headEnd type="none" w="med" len="med"/>
+                      <a:tailEnd type="none" w="med" len="med"/>
+                    </a:lnR>
+                    <a:lnT w="9525" cap="flat" cmpd="sng" algn="ctr">
+                      <a:solidFill>
+                        <a:srgbClr val="2D3140"/>
+                      </a:solidFill>
+                      <a:prstDash val="solid"/>
+                      <a:round/>
+                      <a:headEnd type="none" w="med" len="med"/>
+                      <a:tailEnd type="none" w="med" len="med"/>
+                    </a:lnT>
+                    <a:lnB w="0" cap="flat" cmpd="sng" algn="ctr">
+                      <a:noFill/>
+                    </a:lnB>
+                    <a:solidFill>
                       <a:srgbClr val="1A1D25"/>
                     </a:solidFill>
                   </a:tcPr>
                 </a:tc>
               </a:tr>
-              <a:tr h="742950">
+              <a:tr h="685800">
                 <a:tc>
                   <a:txBody>
                     <a:bodyPr/>
@@ -4855,7 +5039,7 @@
                   </a:tcPr>
                 </a:tc>
               </a:tr>
-              <a:tr h="742950">
+              <a:tr h="685800">
                 <a:tc>
                   <a:txBody>
                     <a:bodyPr/>
@@ -5029,7 +5213,7 @@
         </p:nvSpPr>
         <p:spPr>
           <a:xfrm>
-            <a:off x="914400" y="7219950"/>
+            <a:off x="914400" y="7620000"/>
             <a:ext cx="11430000" cy="428625"/>
           </a:xfrm>
           <a:prstGeom prst="rect">
@@ -5079,7 +5263,7 @@
         </p:nvSpPr>
         <p:spPr>
           <a:xfrm>
-            <a:off x="914400" y="7639050"/>
+            <a:off x="914400" y="8039100"/>
             <a:ext cx="16459200" cy="552450"/>
           </a:xfrm>
           <a:prstGeom prst="rect">
@@ -5195,7 +5379,7 @@
         </p:nvSpPr>
         <p:spPr>
           <a:xfrm>
-            <a:off x="914400" y="8172450"/>
+            <a:off x="914400" y="8572500"/>
             <a:ext cx="16459200" cy="390525"/>
           </a:xfrm>
           <a:prstGeom prst="rect">

</xml_diff>